<commit_message>
Update README with improved usage instructions for transition plan tracker
Co-authored-by: Copilot <copilot@github.com>
</commit_message>
<xml_diff>
--- a/Presentation/Transition Plan.pptx
+++ b/Presentation/Transition Plan.pptx
@@ -121,7 +121,7 @@
   <pc:docChgLst>
     <pc:chgData name="RajasekarDurvas Jayaraman" userId="dec69a9c-1923-4032-83ec-8757405c18aa" providerId="ADAL" clId="{7ADC62E8-6187-4025-8A4D-3ED53A392072}"/>
     <pc:docChg chg="undo custSel addSld delSld modSld sldOrd">
-      <pc:chgData name="RajasekarDurvas Jayaraman" userId="dec69a9c-1923-4032-83ec-8757405c18aa" providerId="ADAL" clId="{7ADC62E8-6187-4025-8A4D-3ED53A392072}" dt="2026-05-08T17:47:10.637" v="259" actId="20577"/>
+      <pc:chgData name="RajasekarDurvas Jayaraman" userId="dec69a9c-1923-4032-83ec-8757405c18aa" providerId="ADAL" clId="{7ADC62E8-6187-4025-8A4D-3ED53A392072}" dt="2026-05-08T18:12:05.557" v="269" actId="13926"/>
       <pc:docMkLst>
         <pc:docMk/>
       </pc:docMkLst>
@@ -133,7 +133,7 @@
         </pc:sldMkLst>
       </pc:sldChg>
       <pc:sldChg chg="addSp delSp modSp new mod setBg">
-        <pc:chgData name="RajasekarDurvas Jayaraman" userId="dec69a9c-1923-4032-83ec-8757405c18aa" providerId="ADAL" clId="{7ADC62E8-6187-4025-8A4D-3ED53A392072}" dt="2026-05-08T17:45:59.867" v="208"/>
+        <pc:chgData name="RajasekarDurvas Jayaraman" userId="dec69a9c-1923-4032-83ec-8757405c18aa" providerId="ADAL" clId="{7ADC62E8-6187-4025-8A4D-3ED53A392072}" dt="2026-05-08T18:12:05.557" v="269" actId="13926"/>
         <pc:sldMkLst>
           <pc:docMk/>
           <pc:sldMk cId="713371610" sldId="257"/>
@@ -147,7 +147,7 @@
           </ac:spMkLst>
         </pc:spChg>
         <pc:spChg chg="mod">
-          <ac:chgData name="RajasekarDurvas Jayaraman" userId="dec69a9c-1923-4032-83ec-8757405c18aa" providerId="ADAL" clId="{7ADC62E8-6187-4025-8A4D-3ED53A392072}" dt="2026-05-08T17:45:42.132" v="206" actId="108"/>
+          <ac:chgData name="RajasekarDurvas Jayaraman" userId="dec69a9c-1923-4032-83ec-8757405c18aa" providerId="ADAL" clId="{7ADC62E8-6187-4025-8A4D-3ED53A392072}" dt="2026-05-08T18:12:05.557" v="269" actId="13926"/>
           <ac:spMkLst>
             <pc:docMk/>
             <pc:sldMk cId="713371610" sldId="257"/>
@@ -243,7 +243,7 @@
         </pc:spChg>
       </pc:sldChg>
       <pc:sldChg chg="modSp add mod ord setBg">
-        <pc:chgData name="RajasekarDurvas Jayaraman" userId="dec69a9c-1923-4032-83ec-8757405c18aa" providerId="ADAL" clId="{7ADC62E8-6187-4025-8A4D-3ED53A392072}" dt="2026-05-08T17:47:10.637" v="259" actId="20577"/>
+        <pc:chgData name="RajasekarDurvas Jayaraman" userId="dec69a9c-1923-4032-83ec-8757405c18aa" providerId="ADAL" clId="{7ADC62E8-6187-4025-8A4D-3ED53A392072}" dt="2026-05-08T18:11:26.762" v="265" actId="13926"/>
         <pc:sldMkLst>
           <pc:docMk/>
           <pc:sldMk cId="3802943353" sldId="259"/>
@@ -257,7 +257,7 @@
           </ac:spMkLst>
         </pc:spChg>
         <pc:spChg chg="mod">
-          <ac:chgData name="RajasekarDurvas Jayaraman" userId="dec69a9c-1923-4032-83ec-8757405c18aa" providerId="ADAL" clId="{7ADC62E8-6187-4025-8A4D-3ED53A392072}" dt="2026-05-08T17:47:10.637" v="259" actId="20577"/>
+          <ac:chgData name="RajasekarDurvas Jayaraman" userId="dec69a9c-1923-4032-83ec-8757405c18aa" providerId="ADAL" clId="{7ADC62E8-6187-4025-8A4D-3ED53A392072}" dt="2026-05-08T18:11:26.762" v="265" actId="13926"/>
           <ac:spMkLst>
             <pc:docMk/>
             <pc:sldMk cId="3802943353" sldId="259"/>
@@ -3896,17 +3896,20 @@
                   </a:schemeClr>
                 </a:solidFill>
               </a:rPr>
-              <a:t>During the knowledge transition process, I initially planned to use Word and Excel files to track progress and share updates with leadership. As the </a:t>
-            </a:r>
-            <a:r>
-              <a:rPr lang="en-US">
+              <a:t>During the knowledge transition process, I initially planned to use Word and Excel files to track progress and share updates with leadership. As the activities increases, </a:t>
+            </a:r>
+            <a:r>
+              <a:rPr lang="en-US" dirty="0">
                 <a:solidFill>
                   <a:schemeClr val="tx1">
                     <a:alpha val="55000"/>
                   </a:schemeClr>
                 </a:solidFill>
+                <a:highlight>
+                  <a:srgbClr val="008080"/>
+                </a:highlight>
               </a:rPr>
-              <a:t>activities increases, </a:t>
+              <a:t>managing and updating the files</a:t>
             </a:r>
             <a:r>
               <a:rPr lang="en-US" dirty="0">
@@ -3916,7 +3919,7 @@
                   </a:schemeClr>
                 </a:solidFill>
               </a:rPr>
-              <a:t>managing and updating the files daily became difficult and time-consuming. </a:t>
+              <a:t> daily became difficult and time-consuming. </a:t>
             </a:r>
           </a:p>
           <a:p>
@@ -3928,7 +3931,30 @@
                   </a:schemeClr>
                 </a:solidFill>
               </a:rPr>
-              <a:t>I also faced challenges creating meaningful status reports and progress insights in Excel. The manual process made it hard to quickly track progress, pending items, and provide clear visibility to leadership.</a:t>
+              <a:t>I also faced challenges creating meaningful status reports and progress insights in Excel. The manual process made it hard to </a:t>
+            </a:r>
+            <a:r>
+              <a:rPr lang="en-US" dirty="0">
+                <a:solidFill>
+                  <a:schemeClr val="tx1">
+                    <a:alpha val="55000"/>
+                  </a:schemeClr>
+                </a:solidFill>
+                <a:highlight>
+                  <a:srgbClr val="008080"/>
+                </a:highlight>
+              </a:rPr>
+              <a:t>quickly track progress, pending items</a:t>
+            </a:r>
+            <a:r>
+              <a:rPr lang="en-US" dirty="0">
+                <a:solidFill>
+                  <a:schemeClr val="tx1">
+                    <a:alpha val="55000"/>
+                  </a:schemeClr>
+                </a:solidFill>
+              </a:rPr>
+              <a:t>, and provide clear visibility to leadership.</a:t>
             </a:r>
           </a:p>
         </p:txBody>
@@ -4338,10 +4364,21 @@
                   </a:schemeClr>
                 </a:solidFill>
               </a:rPr>
-              <a:t>Developed a lightweight single-file HTML app for planning and tracking structured onboarding and handover work between an outgoing and incoming candidate with a basic HTML, CSS and JavaScript application using Claude Code and GitHub Copilot. </a:t>
-            </a:r>
-          </a:p>
-          <a:p>
+              <a:t>Developed a lightweight single-file HTML app for planning and tracking structured onboarding and handover work between an outgoing and incoming candidate with a basic </a:t>
+            </a:r>
+            <a:r>
+              <a:rPr lang="en-US" dirty="0">
+                <a:solidFill>
+                  <a:schemeClr val="tx1">
+                    <a:alpha val="55000"/>
+                  </a:schemeClr>
+                </a:solidFill>
+                <a:highlight>
+                  <a:srgbClr val="008080"/>
+                </a:highlight>
+              </a:rPr>
+              <a:t>HTML, CSS and JavaScript </a:t>
+            </a:r>
             <a:r>
               <a:rPr lang="en-US" dirty="0">
                 <a:solidFill>
@@ -4350,7 +4387,88 @@
                   </a:schemeClr>
                 </a:solidFill>
               </a:rPr>
-              <a:t>This tool enables personalized tracking and leverage code to provide insights, reporting, and monitoring for knowledge transition.</a:t>
+              <a:t>application using </a:t>
+            </a:r>
+            <a:r>
+              <a:rPr lang="en-US" dirty="0">
+                <a:solidFill>
+                  <a:schemeClr val="tx1">
+                    <a:alpha val="55000"/>
+                  </a:schemeClr>
+                </a:solidFill>
+                <a:highlight>
+                  <a:srgbClr val="008080"/>
+                </a:highlight>
+              </a:rPr>
+              <a:t>Claude Code </a:t>
+            </a:r>
+            <a:r>
+              <a:rPr lang="en-US" dirty="0">
+                <a:solidFill>
+                  <a:schemeClr val="tx1">
+                    <a:alpha val="55000"/>
+                  </a:schemeClr>
+                </a:solidFill>
+              </a:rPr>
+              <a:t>and </a:t>
+            </a:r>
+            <a:r>
+              <a:rPr lang="en-US" dirty="0">
+                <a:solidFill>
+                  <a:schemeClr val="tx1">
+                    <a:alpha val="55000"/>
+                  </a:schemeClr>
+                </a:solidFill>
+                <a:highlight>
+                  <a:srgbClr val="008080"/>
+                </a:highlight>
+              </a:rPr>
+              <a:t>GitHub Copilot</a:t>
+            </a:r>
+            <a:r>
+              <a:rPr lang="en-US" dirty="0">
+                <a:solidFill>
+                  <a:schemeClr val="tx1">
+                    <a:alpha val="55000"/>
+                  </a:schemeClr>
+                </a:solidFill>
+              </a:rPr>
+              <a:t>. </a:t>
+            </a:r>
+          </a:p>
+          <a:p>
+            <a:r>
+              <a:rPr lang="en-US" dirty="0">
+                <a:solidFill>
+                  <a:schemeClr val="tx1">
+                    <a:alpha val="55000"/>
+                  </a:schemeClr>
+                </a:solidFill>
+              </a:rPr>
+              <a:t>This tool enables personalized tracking and leverage code to </a:t>
+            </a:r>
+            <a:r>
+              <a:rPr lang="en-US" dirty="0">
+                <a:solidFill>
+                  <a:schemeClr val="tx1">
+                    <a:alpha val="55000"/>
+                  </a:schemeClr>
+                </a:solidFill>
+                <a:highlight>
+                  <a:srgbClr val="008080"/>
+                </a:highlight>
+              </a:rPr>
+              <a:t>provide insights, reporting, and monitoring </a:t>
+            </a:r>
+            <a:r>
+              <a:rPr lang="en-US" dirty="0">
+                <a:solidFill>
+                  <a:schemeClr val="tx1">
+                    <a:alpha val="55000"/>
+                  </a:schemeClr>
+                </a:solidFill>
+              </a:rPr>
+              <a:t>for knowledge transition.</a:t>
             </a:r>
           </a:p>
           <a:p>

</xml_diff>